<commit_message>
Fase0 Task3 completo: deck mancanti nativi + reference PNG + fix apertura (rel slide->layout) + Manrope
</commit_message>
<xml_diff>
--- a/winapps-baseline/test_files/fonts.pptx
+++ b/winapps-baseline/test_files/fonts.pptx
@@ -11,6 +11,7 @@
     <p:sldId id="259" r:id="rId4"/>
     <p:sldId id="260" r:id="rId5"/>
     <p:sldId id="261" r:id="rId6"/>
+    <p:sldId id="262" r:id="rId7"/>
   </p:sldIdLst>
   <p:sldSz cx="12192119" cy="6858000"/>
   <p:notesSz cx="6858000" cy="9144000"/>
@@ -653,6 +654,96 @@
 </p:sld>
 </file>
 
+<file path=ppt/slides/slide7.xml><?xml version="1.0" encoding="utf-8"?>
+<p:sld xmlns:a="http://schemas.openxmlformats.org/drawingml/2006/main" xmlns:r="http://schemas.openxmlformats.org/officeDocument/2006/relationships" xmlns:p="http://schemas.openxmlformats.org/presentationml/2006/main">
+  <p:cSld>
+    <p:spTree>
+      <p:nvGrpSpPr>
+        <p:cNvPr id="1" name=""/>
+        <p:cNvGrpSpPr/>
+        <p:nvPr/>
+      </p:nvGrpSpPr>
+      <p:grpSpPr>
+        <a:xfrm>
+          <a:off x="0" y="0"/>
+          <a:ext cx="0" cy="0"/>
+          <a:chOff x="0" y="0"/>
+          <a:chExt cx="0" cy="0"/>
+        </a:xfrm>
+      </p:grpSpPr>
+      <p:sp>
+        <p:nvSpPr>
+          <p:cNvPr id="2" name="Shape2"/>
+          <p:cNvSpPr/>
+          <p:nvPr/>
+        </p:nvSpPr>
+        <p:spPr>
+          <a:xfrm>
+            <a:off x="359999" y="5976000"/>
+            <a:ext cx="10800000" cy="648000"/>
+          </a:xfrm>
+          <a:prstGeom prst="rect">
+            <a:avLst/>
+          </a:prstGeom>
+          <a:effectLst/>
+        </p:spPr>
+        <p:txBody>
+          <a:bodyPr vertOverflow="clip" anchor="ctr"/>
+          <a:lstStyle/>
+          <a:p>
+            <a:r>
+              <a:rPr lang="en-US" sz="2200" dirty="0">
+                <a:latin typeface="Manrope"/>
+                <a:ea typeface="Manrope"/>
+              </a:rPr>
+              <a:t>Manrope variable (bundled: winapps-baseline/fonts/)</a:t>
+            </a:r>
+          </a:p>
+        </p:txBody>
+      </p:sp>
+      <p:sp>
+        <p:nvSpPr>
+          <p:cNvPr id="3" name="Shape3"/>
+          <p:cNvSpPr/>
+          <p:nvPr/>
+        </p:nvSpPr>
+        <p:spPr>
+          <a:xfrm>
+            <a:off x="359999" y="6660000"/>
+            <a:ext cx="10800000" cy="648000"/>
+          </a:xfrm>
+          <a:prstGeom prst="rect">
+            <a:avLst/>
+          </a:prstGeom>
+          <a:solidFill>
+            <a:srgbClr val="F2F2F2">
+              <a:alpha val="100000"/>
+            </a:srgbClr>
+          </a:solidFill>
+          <a:effectLst/>
+        </p:spPr>
+        <p:txBody>
+          <a:bodyPr vertOverflow="clip" anchor="ctr"/>
+          <a:lstStyle/>
+          <a:p>
+            <a:r>
+              <a:rPr lang="en-US" sz="1600" dirty="0">
+                <a:latin typeface="Manrope"/>
+                <a:ea typeface="Manrope"/>
+              </a:rPr>
+              <a:t>(specified: Manrope)</a:t>
+            </a:r>
+          </a:p>
+        </p:txBody>
+      </p:sp>
+    </p:spTree>
+  </p:cSld>
+  <p:clrMapOvr>
+    <a:masterClrMapping/>
+  </p:clrMapOvr>
+</p:sld>
+</file>
+
 <file path=ppt/theme/theme1.xml><?xml version="1.0" encoding="utf-8"?>
 <a:theme xmlns:a="http://schemas.openxmlformats.org/drawingml/2006/main" name="pptx-open-th">
   <a:themeElements>

</xml_diff>